<commit_message>
upload - final commit
</commit_message>
<xml_diff>
--- a/DATA_MASTER_ENG_DADOS.pptx
+++ b/DATA_MASTER_ENG_DADOS.pptx
@@ -3353,7 +3353,7 @@
           <a:p>
             <a:fld id="{709AB107-10E3-40D5-91C4-6432737E1C37}" type="datetimeFigureOut">
               <a:rPr lang="pt-BR" smtClean="0"/>
-              <a:t>13/04/2026</a:t>
+              <a:t>14/04/2026</a:t>
             </a:fld>
             <a:endParaRPr lang="pt-BR"/>
           </a:p>
@@ -3561,7 +3561,7 @@
           <a:p>
             <a:fld id="{709AB107-10E3-40D5-91C4-6432737E1C37}" type="datetimeFigureOut">
               <a:rPr lang="pt-BR" smtClean="0"/>
-              <a:t>13/04/2026</a:t>
+              <a:t>14/04/2026</a:t>
             </a:fld>
             <a:endParaRPr lang="pt-BR"/>
           </a:p>
@@ -3817,7 +3817,7 @@
           <a:p>
             <a:fld id="{709AB107-10E3-40D5-91C4-6432737E1C37}" type="datetimeFigureOut">
               <a:rPr lang="pt-BR" smtClean="0"/>
-              <a:t>13/04/2026</a:t>
+              <a:t>14/04/2026</a:t>
             </a:fld>
             <a:endParaRPr lang="pt-BR"/>
           </a:p>
@@ -3987,7 +3987,7 @@
           <a:p>
             <a:fld id="{709AB107-10E3-40D5-91C4-6432737E1C37}" type="datetimeFigureOut">
               <a:rPr lang="pt-BR" smtClean="0"/>
-              <a:t>13/04/2026</a:t>
+              <a:t>14/04/2026</a:t>
             </a:fld>
             <a:endParaRPr lang="pt-BR"/>
           </a:p>
@@ -4330,7 +4330,7 @@
           <a:p>
             <a:fld id="{709AB107-10E3-40D5-91C4-6432737E1C37}" type="datetimeFigureOut">
               <a:rPr lang="pt-BR" smtClean="0"/>
-              <a:t>13/04/2026</a:t>
+              <a:t>14/04/2026</a:t>
             </a:fld>
             <a:endParaRPr lang="pt-BR"/>
           </a:p>
@@ -4605,7 +4605,7 @@
           <a:p>
             <a:fld id="{709AB107-10E3-40D5-91C4-6432737E1C37}" type="datetimeFigureOut">
               <a:rPr lang="pt-BR" smtClean="0"/>
-              <a:t>13/04/2026</a:t>
+              <a:t>14/04/2026</a:t>
             </a:fld>
             <a:endParaRPr lang="pt-BR"/>
           </a:p>
@@ -4984,7 +4984,7 @@
           <a:p>
             <a:fld id="{709AB107-10E3-40D5-91C4-6432737E1C37}" type="datetimeFigureOut">
               <a:rPr lang="pt-BR" smtClean="0"/>
-              <a:t>13/04/2026</a:t>
+              <a:t>14/04/2026</a:t>
             </a:fld>
             <a:endParaRPr lang="pt-BR"/>
           </a:p>
@@ -5102,7 +5102,7 @@
           <a:p>
             <a:fld id="{709AB107-10E3-40D5-91C4-6432737E1C37}" type="datetimeFigureOut">
               <a:rPr lang="pt-BR" smtClean="0"/>
-              <a:t>13/04/2026</a:t>
+              <a:t>14/04/2026</a:t>
             </a:fld>
             <a:endParaRPr lang="pt-BR"/>
           </a:p>
@@ -5273,7 +5273,7 @@
           <a:p>
             <a:fld id="{709AB107-10E3-40D5-91C4-6432737E1C37}" type="datetimeFigureOut">
               <a:rPr lang="pt-BR" smtClean="0"/>
-              <a:t>13/04/2026</a:t>
+              <a:t>14/04/2026</a:t>
             </a:fld>
             <a:endParaRPr lang="pt-BR"/>
           </a:p>
@@ -5627,7 +5627,7 @@
           <a:p>
             <a:fld id="{709AB107-10E3-40D5-91C4-6432737E1C37}" type="datetimeFigureOut">
               <a:rPr lang="pt-BR" smtClean="0"/>
-              <a:t>13/04/2026</a:t>
+              <a:t>14/04/2026</a:t>
             </a:fld>
             <a:endParaRPr lang="pt-BR"/>
           </a:p>
@@ -6004,7 +6004,7 @@
           <a:p>
             <a:fld id="{709AB107-10E3-40D5-91C4-6432737E1C37}" type="datetimeFigureOut">
               <a:rPr lang="pt-BR" smtClean="0"/>
-              <a:t>13/04/2026</a:t>
+              <a:t>14/04/2026</a:t>
             </a:fld>
             <a:endParaRPr lang="pt-BR"/>
           </a:p>
@@ -6305,7 +6305,7 @@
           <a:p>
             <a:fld id="{709AB107-10E3-40D5-91C4-6432737E1C37}" type="datetimeFigureOut">
               <a:rPr lang="pt-BR" smtClean="0"/>
-              <a:t>13/04/2026</a:t>
+              <a:t>14/04/2026</a:t>
             </a:fld>
             <a:endParaRPr lang="pt-BR"/>
           </a:p>
@@ -7054,15 +7054,7 @@
             </a:pPr>
             <a:r>
               <a:rPr lang="pt-BR" dirty="0"/>
-              <a:t>Criação de um script completo de configuração do ambiente de Data Warehouse, incluindo definição de grupos, regras de acesso e políticas, permitindo fácil acesso a </a:t>
-            </a:r>
-            <a:r>
-              <a:rPr lang="pt-BR" dirty="0" err="1"/>
-              <a:t>protipação</a:t>
-            </a:r>
-            <a:r>
-              <a:rPr lang="pt-BR" dirty="0"/>
-              <a:t> desse projeto.</a:t>
+              <a:t>Criação de um script completo de configuração do ambiente de Data Warehouse, incluindo definição de grupos, regras de acesso e políticas, permitindo fácil acesso à prototipação do projeto.</a:t>
             </a:r>
           </a:p>
         </p:txBody>

</xml_diff>

<commit_message>
update pdf & ppt
</commit_message>
<xml_diff>
--- a/DATA_MASTER_ENG_DADOS.pptx
+++ b/DATA_MASTER_ENG_DADOS.pptx
@@ -6875,7 +6875,9 @@
         </p:nvSpPr>
         <p:spPr/>
         <p:txBody>
-          <a:bodyPr/>
+          <a:bodyPr>
+            <a:normAutofit fontScale="92500" lnSpcReduction="20000"/>
+          </a:bodyPr>
           <a:lstStyle/>
           <a:p>
             <a:r>
@@ -6907,13 +6909,25 @@
           <a:p>
             <a:r>
               <a:rPr lang="pt-BR" dirty="0"/>
-              <a:t>Fernando Miguel D’Andrea Lima							</a:t>
+              <a:t>Fernando Miguel D’Andrea Lima</a:t>
+            </a:r>
+          </a:p>
+          <a:p>
+            <a:r>
+              <a:rPr lang="pt-BR" dirty="0"/>
+              <a:t>	</a:t>
             </a:r>
             <a:r>
               <a:rPr lang="pt-BR" dirty="0">
                 <a:hlinkClick r:id="rId2"/>
               </a:rPr>
               <a:t>GitHub</a:t>
+            </a:r>
+            <a:r>
+              <a:rPr lang="pt-BR" dirty="0">
+                <a:hlinkClick r:id="rId2"/>
+              </a:rPr>
+              <a:t>: https://github.com/fernandomiguel99/case_data_master_data_eng</a:t>
             </a:r>
             <a:endParaRPr lang="pt-BR" dirty="0"/>
           </a:p>
@@ -8036,7 +8050,7 @@
             </a:r>
             <a:r>
               <a:rPr lang="pt-BR" sz="2000" dirty="0"/>
-              <a:t> para e segurança de acessos;</a:t>
+              <a:t> para gestão e controle de acessos;</a:t>
             </a:r>
           </a:p>
           <a:p>

</xml_diff>